<commit_message>
Insert company branding slide as page 1 of presentation
</commit_message>
<xml_diff>
--- a/Loan_Default_Risk_Analysis_Presentation.pptx
+++ b/Loan_Default_Risk_Analysis_Presentation.pptx
@@ -17,6 +17,7 @@
     <p:sldId id="265" r:id="rId16"/>
     <p:sldId id="266" r:id="rId17"/>
     <p:sldId id="267" r:id="rId18"/>
+    <p:sldId id="268" r:id="rId19"/>
   </p:sldIdLst>
   <p:sldSz cx="12191695" cy="6858000" type="screen4x3"/>
   <p:notesSz cx="6858000" cy="9144000"/>
@@ -3099,12 +3100,20 @@
         <p:nvPr/>
       </p:nvGrpSpPr>
       <p:grpSpPr/>
-      <p:sp>
-        <p:nvSpPr>
-          <p:cNvPr id="2" name="Rectangle 1"/>
-          <p:cNvSpPr/>
+      <p:pic>
+        <p:nvPicPr>
+          <p:cNvPr id="2" name="Picture 1" descr="title_page.png"/>
+          <p:cNvPicPr>
+            <a:picLocks noChangeAspect="1"/>
+          </p:cNvPicPr>
           <p:nvPr/>
-        </p:nvSpPr>
+        </p:nvPicPr>
+        <p:blipFill>
+          <a:blip r:embed="rId2"/>
+          <a:stretch>
+            <a:fillRect/>
+          </a:stretch>
+        </p:blipFill>
         <p:spPr>
           <a:xfrm>
             <a:off x="0" y="0"/>
@@ -3113,147 +3122,8 @@
           <a:prstGeom prst="rect">
             <a:avLst/>
           </a:prstGeom>
-          <a:solidFill>
-            <a:srgbClr val="0F172A"/>
-          </a:solidFill>
-          <a:ln>
-            <a:noFill/>
-          </a:ln>
-        </p:spPr>
-        <p:style>
-          <a:lnRef idx="1">
-            <a:schemeClr val="accent1"/>
-          </a:lnRef>
-          <a:fillRef idx="3">
-            <a:schemeClr val="accent1"/>
-          </a:fillRef>
-          <a:effectRef idx="2">
-            <a:schemeClr val="accent1"/>
-          </a:effectRef>
-          <a:fontRef idx="minor">
-            <a:schemeClr val="lt1"/>
-          </a:fontRef>
-        </p:style>
-        <p:txBody>
-          <a:bodyPr rtlCol="0" anchor="ctr"/>
-          <a:lstStyle/>
-          <a:p>
-            <a:pPr algn="ctr"/>
-          </a:p>
-        </p:txBody>
-      </p:sp>
-      <p:sp>
-        <p:nvSpPr>
-          <p:cNvPr id="3" name="TextBox 2"/>
-          <p:cNvSpPr txBox="1"/>
-          <p:nvPr/>
-        </p:nvSpPr>
-        <p:spPr>
-          <a:xfrm>
-            <a:off x="914400" y="1828800"/>
-            <a:ext cx="10362895" cy="3200400"/>
-          </a:xfrm>
-          <a:prstGeom prst="rect">
-            <a:avLst/>
-          </a:prstGeom>
-          <a:noFill/>
-        </p:spPr>
-        <p:txBody>
-          <a:bodyPr wrap="square">
-            <a:spAutoFit/>
-          </a:bodyPr>
-          <a:lstStyle/>
-          <a:p>
-            <a:pPr>
-              <a:defRPr sz="4000" b="1">
-                <a:solidFill>
-                  <a:srgbClr val="2563EB"/>
-                </a:solidFill>
-                <a:latin typeface="Arial"/>
-              </a:defRPr>
-            </a:pPr>
-            <a:r>
-              <a:t>🏦 Credit Risk Assessment:</a:t>
-            </a:r>
-          </a:p>
-          <a:p>
-            <a:pPr>
-              <a:spcAft>
-                <a:spcPts val="2000"/>
-              </a:spcAft>
-              <a:defRPr sz="4000" b="1">
-                <a:solidFill>
-                  <a:srgbClr val="FFFFFF"/>
-                </a:solidFill>
-                <a:latin typeface="Arial"/>
-              </a:defRPr>
-            </a:pPr>
-            <a:r>
-              <a:t>Loan Default Prediction &amp; Analytics</a:t>
-            </a:r>
-          </a:p>
-          <a:p>
-            <a:pPr>
-              <a:defRPr sz="1800">
-                <a:solidFill>
-                  <a:srgbClr val="F1F5F9"/>
-                </a:solidFill>
-                <a:latin typeface="Arial"/>
-              </a:defRPr>
-            </a:pPr>
-            <a:r>
-              <a:t>An End-to-End Machine Learning Web Dashboard</a:t>
-            </a:r>
-          </a:p>
-        </p:txBody>
-      </p:sp>
-      <p:sp>
-        <p:nvSpPr>
-          <p:cNvPr id="4" name="TextBox 3"/>
-          <p:cNvSpPr txBox="1"/>
-          <p:nvPr/>
-        </p:nvSpPr>
-        <p:spPr>
-          <a:xfrm>
-            <a:off x="914400" y="4754880"/>
-            <a:ext cx="10362895" cy="1371600"/>
-          </a:xfrm>
-          <a:prstGeom prst="rect">
-            <a:avLst/>
-          </a:prstGeom>
-          <a:noFill/>
-        </p:spPr>
-        <p:txBody>
-          <a:bodyPr wrap="none">
-            <a:spAutoFit/>
-          </a:bodyPr>
-          <a:lstStyle/>
-          <a:p>
-            <a:pPr>
-              <a:defRPr sz="1400">
-                <a:solidFill>
-                  <a:srgbClr val="64748B"/>
-                </a:solidFill>
-              </a:defRPr>
-            </a:pPr>
-            <a:r>
-              <a:t>Project Type: Internship Project</a:t>
-            </a:r>
-          </a:p>
-          <a:p>
-            <a:pPr>
-              <a:defRPr sz="1400">
-                <a:solidFill>
-                  <a:srgbClr val="64748B"/>
-                </a:solidFill>
-              </a:defRPr>
-            </a:pPr>
-            <a:r>
-              <a:t>Domain: Data Analytics  |  Year: 2026</a:t>
-            </a:r>
-          </a:p>
-        </p:txBody>
-      </p:sp>
+        </p:spPr>
+      </p:pic>
     </p:spTree>
   </p:cSld>
   <p:clrMapOvr>
@@ -3389,7 +3259,7 @@
               </a:defRPr>
             </a:pPr>
             <a:r>
-              <a:t>Interactive Web Dashboard Implementation</a:t>
+              <a:t>Feature Importance Analysis</a:t>
             </a:r>
           </a:p>
         </p:txBody>
@@ -3454,7 +3324,7 @@
           <a:p>
             <a:pPr>
               <a:spcAft>
-                <a:spcPts val="1200"/>
+                <a:spcPts val="1000"/>
               </a:spcAft>
               <a:defRPr sz="2000" b="1">
                 <a:solidFill>
@@ -3463,67 +3333,157 @@
               </a:defRPr>
             </a:pPr>
             <a:r>
-              <a:t>💻 Technical Architecture</a:t>
-            </a:r>
-          </a:p>
-          <a:p>
-            <a:pPr>
-              <a:spcAft>
-                <a:spcPts val="1000"/>
-              </a:spcAft>
-              <a:defRPr sz="1350">
+              <a:t>🏗️ Top 10 Most Important Features</a:t>
+            </a:r>
+          </a:p>
+          <a:p>
+            <a:pPr>
+              <a:spcAft>
+                <a:spcPts val="400"/>
+              </a:spcAft>
+              <a:defRPr sz="1350" b="1">
                 <a:solidFill>
                   <a:srgbClr val="1E293B"/>
                 </a:solidFill>
               </a:defRPr>
             </a:pPr>
             <a:r>
-              <a:t>• Framework: Developed completely in Python using Streamlit for rapid deployment.</a:t>
-            </a:r>
-          </a:p>
-          <a:p>
-            <a:pPr>
-              <a:spcAft>
-                <a:spcPts val="1000"/>
-              </a:spcAft>
-              <a:defRPr sz="1350">
+              <a:t>1. Income (12.6%)</a:t>
+            </a:r>
+          </a:p>
+          <a:p>
+            <a:pPr>
+              <a:spcAft>
+                <a:spcPts val="400"/>
+              </a:spcAft>
+              <a:defRPr sz="1350" b="1">
                 <a:solidFill>
                   <a:srgbClr val="1E293B"/>
                 </a:solidFill>
               </a:defRPr>
             </a:pPr>
             <a:r>
-              <a:t>• Visuals: Fully interactive Plotly Express charts with hovering and filtering options.</a:t>
-            </a:r>
-          </a:p>
-          <a:p>
-            <a:pPr>
-              <a:spcAft>
-                <a:spcPts val="1000"/>
-              </a:spcAft>
-              <a:defRPr sz="1350">
+              <a:t>2. InterestRate (12.1%)</a:t>
+            </a:r>
+          </a:p>
+          <a:p>
+            <a:pPr>
+              <a:spcAft>
+                <a:spcPts val="400"/>
+              </a:spcAft>
+              <a:defRPr sz="1350" b="1">
                 <a:solidFill>
                   <a:srgbClr val="1E293B"/>
                 </a:solidFill>
               </a:defRPr>
             </a:pPr>
             <a:r>
-              <a:t>• Model Integration: Pre-trained scaler and models loaded via joblib for instant predictions.</a:t>
-            </a:r>
-          </a:p>
-          <a:p>
-            <a:pPr>
-              <a:spcAft>
-                <a:spcPts val="1000"/>
-              </a:spcAft>
-              <a:defRPr sz="1350">
+              <a:t>3. LoanAmount (11.3%)</a:t>
+            </a:r>
+          </a:p>
+          <a:p>
+            <a:pPr>
+              <a:spcAft>
+                <a:spcPts val="400"/>
+              </a:spcAft>
+              <a:defRPr sz="1350" b="1">
                 <a:solidFill>
                   <a:srgbClr val="1E293B"/>
                 </a:solidFill>
               </a:defRPr>
             </a:pPr>
             <a:r>
-              <a:t>• Responsive Styling: Custom dark-mode UI with high-contrast metric layouts.</a:t>
+              <a:t>4. Age (10.3%)</a:t>
+            </a:r>
+          </a:p>
+          <a:p>
+            <a:pPr>
+              <a:spcAft>
+                <a:spcPts val="400"/>
+              </a:spcAft>
+              <a:defRPr sz="1350" b="1">
+                <a:solidFill>
+                  <a:srgbClr val="1E293B"/>
+                </a:solidFill>
+              </a:defRPr>
+            </a:pPr>
+            <a:r>
+              <a:t>5. CreditScore (10.1%)</a:t>
+            </a:r>
+          </a:p>
+          <a:p>
+            <a:pPr>
+              <a:spcAft>
+                <a:spcPts val="400"/>
+              </a:spcAft>
+              <a:defRPr sz="1350" b="1">
+                <a:solidFill>
+                  <a:srgbClr val="1E293B"/>
+                </a:solidFill>
+              </a:defRPr>
+            </a:pPr>
+            <a:r>
+              <a:t>6. MonthsEmployed (9.8%)</a:t>
+            </a:r>
+          </a:p>
+          <a:p>
+            <a:pPr>
+              <a:spcAft>
+                <a:spcPts val="400"/>
+              </a:spcAft>
+              <a:defRPr sz="1350" b="1">
+                <a:solidFill>
+                  <a:srgbClr val="1E293B"/>
+                </a:solidFill>
+              </a:defRPr>
+            </a:pPr>
+            <a:r>
+              <a:t>7. DTIRatio (8.8%)</a:t>
+            </a:r>
+          </a:p>
+          <a:p>
+            <a:pPr>
+              <a:spcAft>
+                <a:spcPts val="400"/>
+              </a:spcAft>
+              <a:defRPr sz="1350" b="1">
+                <a:solidFill>
+                  <a:srgbClr val="1E293B"/>
+                </a:solidFill>
+              </a:defRPr>
+            </a:pPr>
+            <a:r>
+              <a:t>8. LoanTerm (4.1%)</a:t>
+            </a:r>
+          </a:p>
+          <a:p>
+            <a:pPr>
+              <a:spcAft>
+                <a:spcPts val="400"/>
+              </a:spcAft>
+              <a:defRPr sz="1350" b="1">
+                <a:solidFill>
+                  <a:srgbClr val="1E293B"/>
+                </a:solidFill>
+              </a:defRPr>
+            </a:pPr>
+            <a:r>
+              <a:t>9. NumCreditLines (3.3%)</a:t>
+            </a:r>
+          </a:p>
+          <a:p>
+            <a:pPr>
+              <a:spcAft>
+                <a:spcPts val="400"/>
+              </a:spcAft>
+              <a:defRPr sz="1350" b="1">
+                <a:solidFill>
+                  <a:srgbClr val="1E293B"/>
+                </a:solidFill>
+              </a:defRPr>
+            </a:pPr>
+            <a:r>
+              <a:t>10. EmploymentType (2.5%)</a:t>
             </a:r>
           </a:p>
         </p:txBody>
@@ -3561,7 +3521,7 @@
               </a:defRPr>
             </a:pPr>
             <a:r>
-              <a:t>💡 Interactive Features</a:t>
+              <a:t>📊 Key Findings</a:t>
             </a:r>
           </a:p>
           <a:p>
@@ -3576,7 +3536,7 @@
               </a:defRPr>
             </a:pPr>
             <a:r>
-              <a:t>✓ Interactive EDA: Allows risk officers to segment distributions and view correlation heatmaps dynamically.</a:t>
+              <a:t>• Financial Strengths rule risk assessment: Income, Loan Amount, and DTI represent the most critical risk drivers.</a:t>
             </a:r>
           </a:p>
           <a:p>
@@ -3591,7 +3551,7 @@
               </a:defRPr>
             </a:pPr>
             <a:r>
-              <a:t>✓ Probability Gauge: Displays the exact default risk percentage for input parameters.</a:t>
+              <a:t>• Pricing risk: Interest Rate is a high predictor, indicating that borrowers assigned high-interest loans default at much higher rates.</a:t>
             </a:r>
           </a:p>
           <a:p>
@@ -3606,22 +3566,7 @@
               </a:defRPr>
             </a:pPr>
             <a:r>
-              <a:t>✓ Risk Tier Alert: Categorizes borrowers into Low, Medium, and High-risk tiers.</a:t>
-            </a:r>
-          </a:p>
-          <a:p>
-            <a:pPr>
-              <a:spcAft>
-                <a:spcPts val="1000"/>
-              </a:spcAft>
-              <a:defRPr sz="1350">
-                <a:solidFill>
-                  <a:srgbClr val="1E293B"/>
-                </a:solidFill>
-              </a:defRPr>
-            </a:pPr>
-            <a:r>
-              <a:t>✓ Dataset Download: Streamlines exporting the entire preprocessed dataset.</a:t>
+              <a:t>• Borrower history: Credit score, age, and employment stability (MonthsEmployed) provide critical contextual signals that prevent false approvals.</a:t>
             </a:r>
           </a:p>
         </p:txBody>
@@ -3761,7 +3706,7 @@
               </a:defRPr>
             </a:pPr>
             <a:r>
-              <a:t>Business Impact &amp; Actionable Recommendations</a:t>
+              <a:t>Interactive Web Dashboard Implementation</a:t>
             </a:r>
           </a:p>
         </p:txBody>
@@ -3811,7 +3756,7 @@
         <p:spPr>
           <a:xfrm>
             <a:off x="548640" y="1645920"/>
-            <a:ext cx="11064240" cy="4572000"/>
+            <a:ext cx="5303520" cy="4114800"/>
           </a:xfrm>
           <a:prstGeom prst="rect">
             <a:avLst/>
@@ -3835,7 +3780,7 @@
               </a:defRPr>
             </a:pPr>
             <a:r>
-              <a:t>📈 Policy Action Items</a:t>
+              <a:t>💻 Technical Architecture</a:t>
             </a:r>
           </a:p>
           <a:p>
@@ -3843,14 +3788,14 @@
               <a:spcAft>
                 <a:spcPts val="1000"/>
               </a:spcAft>
-              <a:defRPr sz="1400">
+              <a:defRPr sz="1350">
                 <a:solidFill>
                   <a:srgbClr val="1E293B"/>
                 </a:solidFill>
               </a:defRPr>
             </a:pPr>
             <a:r>
-              <a:t>1. Dynamic Interest Rate Capping: Constrain interest rates under 15% for applicants with borderline credit scores unless a co-signer is present.</a:t>
+              <a:t>• Framework: Developed completely in Python using Streamlit for rapid deployment.</a:t>
             </a:r>
           </a:p>
           <a:p>
@@ -3858,14 +3803,14 @@
               <a:spcAft>
                 <a:spcPts val="1000"/>
               </a:spcAft>
-              <a:defRPr sz="1400">
+              <a:defRPr sz="1350">
                 <a:solidFill>
                   <a:srgbClr val="1E293B"/>
                 </a:solidFill>
               </a:defRPr>
             </a:pPr>
             <a:r>
-              <a:t>2. Strict Debt-to-Income Rules: Implement automated secondary audits for applicants exceeding the 40% DTI risk threshold.</a:t>
+              <a:t>• Visuals: Fully interactive Plotly Express charts with hovering and filtering options.</a:t>
             </a:r>
           </a:p>
           <a:p>
@@ -3873,14 +3818,14 @@
               <a:spcAft>
                 <a:spcPts val="1000"/>
               </a:spcAft>
-              <a:defRPr sz="1400">
+              <a:defRPr sz="1350">
                 <a:solidFill>
                   <a:srgbClr val="1E293B"/>
                 </a:solidFill>
               </a:defRPr>
             </a:pPr>
             <a:r>
-              <a:t>3. Focus on Co-Signer Incentives: Offer lower rates or terms to high-risk profiles if they include a qualified co-signer to offset default risk.</a:t>
+              <a:t>• Model Integration: Pre-trained scaler and models loaded via joblib for instant predictions.</a:t>
             </a:r>
           </a:p>
           <a:p>
@@ -3888,14 +3833,112 @@
               <a:spcAft>
                 <a:spcPts val="1000"/>
               </a:spcAft>
-              <a:defRPr sz="1400">
+              <a:defRPr sz="1350">
                 <a:solidFill>
                   <a:srgbClr val="1E293B"/>
                 </a:solidFill>
               </a:defRPr>
             </a:pPr>
             <a:r>
-              <a:t>4. Operationalizing False Positives: Route the 8,235 flagged borderline applicants to manual credit agents rather than declining automatically. This protects client relations while weeding out true defaulters.</a:t>
+              <a:t>• Responsive Styling: Custom dark-mode UI with high-contrast metric layouts.</a:t>
+            </a:r>
+          </a:p>
+        </p:txBody>
+      </p:sp>
+      <p:sp>
+        <p:nvSpPr>
+          <p:cNvPr id="7" name="TextBox 6"/>
+          <p:cNvSpPr txBox="1"/>
+          <p:nvPr/>
+        </p:nvSpPr>
+        <p:spPr>
+          <a:xfrm>
+            <a:off x="6217920" y="1645920"/>
+            <a:ext cx="5303520" cy="4114800"/>
+          </a:xfrm>
+          <a:prstGeom prst="rect">
+            <a:avLst/>
+          </a:prstGeom>
+          <a:noFill/>
+        </p:spPr>
+        <p:txBody>
+          <a:bodyPr wrap="square">
+            <a:spAutoFit/>
+          </a:bodyPr>
+          <a:lstStyle/>
+          <a:p>
+            <a:pPr>
+              <a:spcAft>
+                <a:spcPts val="1200"/>
+              </a:spcAft>
+              <a:defRPr sz="2000" b="1">
+                <a:solidFill>
+                  <a:srgbClr val="2563EB"/>
+                </a:solidFill>
+              </a:defRPr>
+            </a:pPr>
+            <a:r>
+              <a:t>💡 Interactive Features</a:t>
+            </a:r>
+          </a:p>
+          <a:p>
+            <a:pPr>
+              <a:spcAft>
+                <a:spcPts val="1000"/>
+              </a:spcAft>
+              <a:defRPr sz="1350">
+                <a:solidFill>
+                  <a:srgbClr val="1E293B"/>
+                </a:solidFill>
+              </a:defRPr>
+            </a:pPr>
+            <a:r>
+              <a:t>✓ Interactive EDA: Allows risk officers to segment distributions and view correlation heatmaps dynamically.</a:t>
+            </a:r>
+          </a:p>
+          <a:p>
+            <a:pPr>
+              <a:spcAft>
+                <a:spcPts val="1000"/>
+              </a:spcAft>
+              <a:defRPr sz="1350">
+                <a:solidFill>
+                  <a:srgbClr val="1E293B"/>
+                </a:solidFill>
+              </a:defRPr>
+            </a:pPr>
+            <a:r>
+              <a:t>✓ Probability Gauge: Displays the exact default risk percentage for input parameters.</a:t>
+            </a:r>
+          </a:p>
+          <a:p>
+            <a:pPr>
+              <a:spcAft>
+                <a:spcPts val="1000"/>
+              </a:spcAft>
+              <a:defRPr sz="1350">
+                <a:solidFill>
+                  <a:srgbClr val="1E293B"/>
+                </a:solidFill>
+              </a:defRPr>
+            </a:pPr>
+            <a:r>
+              <a:t>✓ Risk Tier Alert: Categorizes borrowers into Low, Medium, and High-risk tiers.</a:t>
+            </a:r>
+          </a:p>
+          <a:p>
+            <a:pPr>
+              <a:spcAft>
+                <a:spcPts val="1000"/>
+              </a:spcAft>
+              <a:defRPr sz="1350">
+                <a:solidFill>
+                  <a:srgbClr val="1E293B"/>
+                </a:solidFill>
+              </a:defRPr>
+            </a:pPr>
+            <a:r>
+              <a:t>✓ Dataset Download: Streamlines exporting the entire preprocessed dataset.</a:t>
             </a:r>
           </a:p>
         </p:txBody>
@@ -3933,6 +3976,280 @@
             <a:avLst/>
           </a:prstGeom>
           <a:solidFill>
+            <a:srgbClr val="F8FAFC"/>
+          </a:solidFill>
+          <a:ln>
+            <a:noFill/>
+          </a:ln>
+        </p:spPr>
+        <p:style>
+          <a:lnRef idx="1">
+            <a:schemeClr val="accent1"/>
+          </a:lnRef>
+          <a:fillRef idx="3">
+            <a:schemeClr val="accent1"/>
+          </a:fillRef>
+          <a:effectRef idx="2">
+            <a:schemeClr val="accent1"/>
+          </a:effectRef>
+          <a:fontRef idx="minor">
+            <a:schemeClr val="lt1"/>
+          </a:fontRef>
+        </p:style>
+        <p:txBody>
+          <a:bodyPr rtlCol="0" anchor="ctr"/>
+          <a:lstStyle/>
+          <a:p>
+            <a:pPr algn="ctr"/>
+          </a:p>
+        </p:txBody>
+      </p:sp>
+      <p:sp>
+        <p:nvSpPr>
+          <p:cNvPr id="3" name="Rectangle 2"/>
+          <p:cNvSpPr/>
+          <p:nvPr/>
+        </p:nvSpPr>
+        <p:spPr>
+          <a:xfrm>
+            <a:off x="0" y="0"/>
+            <a:ext cx="12191695" cy="1005840"/>
+          </a:xfrm>
+          <a:prstGeom prst="rect">
+            <a:avLst/>
+          </a:prstGeom>
+          <a:solidFill>
+            <a:srgbClr val="0F172A"/>
+          </a:solidFill>
+          <a:ln>
+            <a:noFill/>
+          </a:ln>
+        </p:spPr>
+        <p:style>
+          <a:lnRef idx="1">
+            <a:schemeClr val="accent1"/>
+          </a:lnRef>
+          <a:fillRef idx="3">
+            <a:schemeClr val="accent1"/>
+          </a:fillRef>
+          <a:effectRef idx="2">
+            <a:schemeClr val="accent1"/>
+          </a:effectRef>
+          <a:fontRef idx="minor">
+            <a:schemeClr val="lt1"/>
+          </a:fontRef>
+        </p:style>
+        <p:txBody>
+          <a:bodyPr rtlCol="0" anchor="ctr"/>
+          <a:lstStyle/>
+          <a:p>
+            <a:pPr algn="ctr"/>
+          </a:p>
+        </p:txBody>
+      </p:sp>
+      <p:sp>
+        <p:nvSpPr>
+          <p:cNvPr id="4" name="TextBox 3"/>
+          <p:cNvSpPr txBox="1"/>
+          <p:nvPr/>
+        </p:nvSpPr>
+        <p:spPr>
+          <a:xfrm>
+            <a:off x="548640" y="182880"/>
+            <a:ext cx="10972800" cy="731520"/>
+          </a:xfrm>
+          <a:prstGeom prst="rect">
+            <a:avLst/>
+          </a:prstGeom>
+          <a:noFill/>
+        </p:spPr>
+        <p:txBody>
+          <a:bodyPr wrap="square">
+            <a:spAutoFit/>
+          </a:bodyPr>
+          <a:lstStyle/>
+          <a:p>
+            <a:pPr>
+              <a:defRPr sz="2800" b="1">
+                <a:solidFill>
+                  <a:srgbClr val="FFFFFF"/>
+                </a:solidFill>
+                <a:latin typeface="Arial"/>
+              </a:defRPr>
+            </a:pPr>
+            <a:r>
+              <a:t>Business Impact &amp; Actionable Recommendations</a:t>
+            </a:r>
+          </a:p>
+        </p:txBody>
+      </p:sp>
+      <p:sp>
+        <p:nvSpPr>
+          <p:cNvPr id="5" name="TextBox 4"/>
+          <p:cNvSpPr txBox="1"/>
+          <p:nvPr/>
+        </p:nvSpPr>
+        <p:spPr>
+          <a:xfrm>
+            <a:off x="548640" y="6492240"/>
+            <a:ext cx="10972800" cy="274320"/>
+          </a:xfrm>
+          <a:prstGeom prst="rect">
+            <a:avLst/>
+          </a:prstGeom>
+          <a:noFill/>
+        </p:spPr>
+        <p:txBody>
+          <a:bodyPr wrap="none">
+            <a:spAutoFit/>
+          </a:bodyPr>
+          <a:lstStyle/>
+          <a:p>
+            <a:pPr>
+              <a:defRPr sz="1000">
+                <a:solidFill>
+                  <a:srgbClr val="64748B"/>
+                </a:solidFill>
+                <a:latin typeface="Arial"/>
+              </a:defRPr>
+            </a:pPr>
+            <a:r>
+              <a:t>Internship Project  |  Data Analytics  |  Year 2026</a:t>
+            </a:r>
+          </a:p>
+        </p:txBody>
+      </p:sp>
+      <p:sp>
+        <p:nvSpPr>
+          <p:cNvPr id="6" name="TextBox 5"/>
+          <p:cNvSpPr txBox="1"/>
+          <p:nvPr/>
+        </p:nvSpPr>
+        <p:spPr>
+          <a:xfrm>
+            <a:off x="548640" y="1645920"/>
+            <a:ext cx="11064240" cy="4572000"/>
+          </a:xfrm>
+          <a:prstGeom prst="rect">
+            <a:avLst/>
+          </a:prstGeom>
+          <a:noFill/>
+        </p:spPr>
+        <p:txBody>
+          <a:bodyPr wrap="square">
+            <a:spAutoFit/>
+          </a:bodyPr>
+          <a:lstStyle/>
+          <a:p>
+            <a:pPr>
+              <a:spcAft>
+                <a:spcPts val="1200"/>
+              </a:spcAft>
+              <a:defRPr sz="2000" b="1">
+                <a:solidFill>
+                  <a:srgbClr val="2563EB"/>
+                </a:solidFill>
+              </a:defRPr>
+            </a:pPr>
+            <a:r>
+              <a:t>📈 Policy Action Items</a:t>
+            </a:r>
+          </a:p>
+          <a:p>
+            <a:pPr>
+              <a:spcAft>
+                <a:spcPts val="1000"/>
+              </a:spcAft>
+              <a:defRPr sz="1400">
+                <a:solidFill>
+                  <a:srgbClr val="1E293B"/>
+                </a:solidFill>
+              </a:defRPr>
+            </a:pPr>
+            <a:r>
+              <a:t>1. Dynamic Interest Rate Capping: Constrain interest rates under 15% for applicants with borderline credit scores unless a co-signer is present.</a:t>
+            </a:r>
+          </a:p>
+          <a:p>
+            <a:pPr>
+              <a:spcAft>
+                <a:spcPts val="1000"/>
+              </a:spcAft>
+              <a:defRPr sz="1400">
+                <a:solidFill>
+                  <a:srgbClr val="1E293B"/>
+                </a:solidFill>
+              </a:defRPr>
+            </a:pPr>
+            <a:r>
+              <a:t>2. Strict Debt-to-Income Rules: Implement automated secondary audits for applicants exceeding the 40% DTI risk threshold.</a:t>
+            </a:r>
+          </a:p>
+          <a:p>
+            <a:pPr>
+              <a:spcAft>
+                <a:spcPts val="1000"/>
+              </a:spcAft>
+              <a:defRPr sz="1400">
+                <a:solidFill>
+                  <a:srgbClr val="1E293B"/>
+                </a:solidFill>
+              </a:defRPr>
+            </a:pPr>
+            <a:r>
+              <a:t>3. Focus on Co-Signer Incentives: Offer lower rates or terms to high-risk profiles if they include a qualified co-signer to offset default risk.</a:t>
+            </a:r>
+          </a:p>
+          <a:p>
+            <a:pPr>
+              <a:spcAft>
+                <a:spcPts val="1000"/>
+              </a:spcAft>
+              <a:defRPr sz="1400">
+                <a:solidFill>
+                  <a:srgbClr val="1E293B"/>
+                </a:solidFill>
+              </a:defRPr>
+            </a:pPr>
+            <a:r>
+              <a:t>4. Operationalizing False Positives: Route the 8,235 flagged borderline applicants to manual credit agents rather than declining automatically. This protects client relations while weeding out true defaulters.</a:t>
+            </a:r>
+          </a:p>
+        </p:txBody>
+      </p:sp>
+    </p:spTree>
+  </p:cSld>
+  <p:clrMapOvr>
+    <a:masterClrMapping/>
+  </p:clrMapOvr>
+</p:sld>
+</file>
+
+<file path=ppt/slides/slide13.xml><?xml version="1.0" encoding="utf-8"?>
+<p:sld xmlns:a="http://schemas.openxmlformats.org/drawingml/2006/main" xmlns:p="http://schemas.openxmlformats.org/presentationml/2006/main" xmlns:r="http://schemas.openxmlformats.org/officeDocument/2006/relationships">
+  <p:cSld>
+    <p:spTree>
+      <p:nvGrpSpPr>
+        <p:cNvPr id="1" name=""/>
+        <p:cNvGrpSpPr/>
+        <p:nvPr/>
+      </p:nvGrpSpPr>
+      <p:grpSpPr/>
+      <p:sp>
+        <p:nvSpPr>
+          <p:cNvPr id="2" name="Rectangle 1"/>
+          <p:cNvSpPr/>
+          <p:nvPr/>
+        </p:nvSpPr>
+        <p:spPr>
+          <a:xfrm>
+            <a:off x="0" y="0"/>
+            <a:ext cx="12191695" cy="6858000"/>
+          </a:xfrm>
+          <a:prstGeom prst="rect">
+            <a:avLst/>
+          </a:prstGeom>
+          <a:solidFill>
             <a:srgbClr val="0F172A"/>
           </a:solidFill>
           <a:ln>
@@ -4059,7 +4376,7 @@
             <a:avLst/>
           </a:prstGeom>
           <a:solidFill>
-            <a:srgbClr val="F8FAFC"/>
+            <a:srgbClr val="0F172A"/>
           </a:solidFill>
           <a:ln>
             <a:noFill/>
@@ -4089,57 +4406,14 @@
       </p:sp>
       <p:sp>
         <p:nvSpPr>
-          <p:cNvPr id="3" name="Rectangle 2"/>
-          <p:cNvSpPr/>
-          <p:nvPr/>
-        </p:nvSpPr>
-        <p:spPr>
-          <a:xfrm>
-            <a:off x="0" y="0"/>
-            <a:ext cx="12191695" cy="1005840"/>
-          </a:xfrm>
-          <a:prstGeom prst="rect">
-            <a:avLst/>
-          </a:prstGeom>
-          <a:solidFill>
-            <a:srgbClr val="0F172A"/>
-          </a:solidFill>
-          <a:ln>
-            <a:noFill/>
-          </a:ln>
-        </p:spPr>
-        <p:style>
-          <a:lnRef idx="1">
-            <a:schemeClr val="accent1"/>
-          </a:lnRef>
-          <a:fillRef idx="3">
-            <a:schemeClr val="accent1"/>
-          </a:fillRef>
-          <a:effectRef idx="2">
-            <a:schemeClr val="accent1"/>
-          </a:effectRef>
-          <a:fontRef idx="minor">
-            <a:schemeClr val="lt1"/>
-          </a:fontRef>
-        </p:style>
-        <p:txBody>
-          <a:bodyPr rtlCol="0" anchor="ctr"/>
-          <a:lstStyle/>
-          <a:p>
-            <a:pPr algn="ctr"/>
-          </a:p>
-        </p:txBody>
-      </p:sp>
-      <p:sp>
-        <p:nvSpPr>
-          <p:cNvPr id="4" name="TextBox 3"/>
+          <p:cNvPr id="3" name="TextBox 2"/>
           <p:cNvSpPr txBox="1"/>
           <p:nvPr/>
         </p:nvSpPr>
         <p:spPr>
           <a:xfrm>
-            <a:off x="548640" y="182880"/>
-            <a:ext cx="10972800" cy="731520"/>
+            <a:off x="914400" y="1828800"/>
+            <a:ext cx="10362895" cy="3200400"/>
           </a:xfrm>
           <a:prstGeom prst="rect">
             <a:avLst/>
@@ -4153,7 +4427,23 @@
           <a:lstStyle/>
           <a:p>
             <a:pPr>
-              <a:defRPr sz="2800" b="1">
+              <a:defRPr sz="4000" b="1">
+                <a:solidFill>
+                  <a:srgbClr val="2563EB"/>
+                </a:solidFill>
+                <a:latin typeface="Arial"/>
+              </a:defRPr>
+            </a:pPr>
+            <a:r>
+              <a:t>🏦 Credit Risk Assessment:</a:t>
+            </a:r>
+          </a:p>
+          <a:p>
+            <a:pPr>
+              <a:spcAft>
+                <a:spcPts val="2000"/>
+              </a:spcAft>
+              <a:defRPr sz="4000" b="1">
                 <a:solidFill>
                   <a:srgbClr val="FFFFFF"/>
                 </a:solidFill>
@@ -4161,21 +4451,34 @@
               </a:defRPr>
             </a:pPr>
             <a:r>
-              <a:t>Problem Statement &amp; Objectives</a:t>
-            </a:r>
-          </a:p>
-        </p:txBody>
-      </p:sp>
-      <p:sp>
-        <p:nvSpPr>
-          <p:cNvPr id="5" name="TextBox 4"/>
+              <a:t>Loan Default Prediction &amp; Analytics</a:t>
+            </a:r>
+          </a:p>
+          <a:p>
+            <a:pPr>
+              <a:defRPr sz="1800">
+                <a:solidFill>
+                  <a:srgbClr val="F1F5F9"/>
+                </a:solidFill>
+                <a:latin typeface="Arial"/>
+              </a:defRPr>
+            </a:pPr>
+            <a:r>
+              <a:t>An End-to-End Machine Learning Web Dashboard</a:t>
+            </a:r>
+          </a:p>
+        </p:txBody>
+      </p:sp>
+      <p:sp>
+        <p:nvSpPr>
+          <p:cNvPr id="4" name="TextBox 3"/>
           <p:cNvSpPr txBox="1"/>
           <p:nvPr/>
         </p:nvSpPr>
         <p:spPr>
           <a:xfrm>
-            <a:off x="548640" y="6492240"/>
-            <a:ext cx="10972800" cy="274320"/>
+            <a:off x="914400" y="4754880"/>
+            <a:ext cx="10362895" cy="1371600"/>
           </a:xfrm>
           <a:prstGeom prst="rect">
             <a:avLst/>
@@ -4189,181 +4492,26 @@
           <a:lstStyle/>
           <a:p>
             <a:pPr>
-              <a:defRPr sz="1000">
+              <a:defRPr sz="1400">
                 <a:solidFill>
                   <a:srgbClr val="64748B"/>
                 </a:solidFill>
-                <a:latin typeface="Arial"/>
-              </a:defRPr>
-            </a:pPr>
-            <a:r>
-              <a:t>Internship Project  |  Data Analytics  |  Year 2026</a:t>
-            </a:r>
-          </a:p>
-        </p:txBody>
-      </p:sp>
-      <p:sp>
-        <p:nvSpPr>
-          <p:cNvPr id="6" name="TextBox 5"/>
-          <p:cNvSpPr txBox="1"/>
-          <p:nvPr/>
-        </p:nvSpPr>
-        <p:spPr>
-          <a:xfrm>
-            <a:off x="548640" y="1463040"/>
-            <a:ext cx="5303520" cy="4572000"/>
-          </a:xfrm>
-          <a:prstGeom prst="rect">
-            <a:avLst/>
-          </a:prstGeom>
-          <a:noFill/>
-        </p:spPr>
-        <p:txBody>
-          <a:bodyPr wrap="square">
-            <a:spAutoFit/>
-          </a:bodyPr>
-          <a:lstStyle/>
-          <a:p>
-            <a:pPr>
-              <a:spcAft>
-                <a:spcPts val="1000"/>
-              </a:spcAft>
-              <a:defRPr sz="2000" b="1">
-                <a:solidFill>
-                  <a:srgbClr val="2563EB"/>
-                </a:solidFill>
-              </a:defRPr>
-            </a:pPr>
-            <a:r>
-              <a:t>🔴 The Core Challenge</a:t>
-            </a:r>
-          </a:p>
-          <a:p>
-            <a:pPr>
-              <a:spcAft>
-                <a:spcPts val="1200"/>
-              </a:spcAft>
+              </a:defRPr>
+            </a:pPr>
+            <a:r>
+              <a:t>Project Type: Internship Project</a:t>
+            </a:r>
+          </a:p>
+          <a:p>
+            <a:pPr>
               <a:defRPr sz="1400">
                 <a:solidFill>
-                  <a:srgbClr val="1E293B"/>
-                </a:solidFill>
-              </a:defRPr>
-            </a:pPr>
-            <a:r>
-              <a:t>• Financial institutions lose billions annually due to non-performing loans (defaults).</a:t>
-            </a:r>
-          </a:p>
-          <a:p>
-            <a:pPr>
-              <a:spcAft>
-                <a:spcPts val="1200"/>
-              </a:spcAft>
-              <a:defRPr sz="1400">
-                <a:solidFill>
-                  <a:srgbClr val="1E293B"/>
-                </a:solidFill>
-              </a:defRPr>
-            </a:pPr>
-            <a:r>
-              <a:t>• Traditional credit scoring methods are static and miss complex risk factor interactions.</a:t>
-            </a:r>
-          </a:p>
-          <a:p>
-            <a:pPr>
-              <a:spcAft>
-                <a:spcPts val="1200"/>
-              </a:spcAft>
-              <a:defRPr sz="1400">
-                <a:solidFill>
-                  <a:srgbClr val="1E293B"/>
-                </a:solidFill>
-              </a:defRPr>
-            </a:pPr>
-            <a:r>
-              <a:t>• Missing a default (False Negative) is highly critical and expensive compared to incorrectly declining a good customer (False Positive).</a:t>
-            </a:r>
-          </a:p>
-        </p:txBody>
-      </p:sp>
-      <p:sp>
-        <p:nvSpPr>
-          <p:cNvPr id="7" name="TextBox 6"/>
-          <p:cNvSpPr txBox="1"/>
-          <p:nvPr/>
-        </p:nvSpPr>
-        <p:spPr>
-          <a:xfrm>
-            <a:off x="6217920" y="1463040"/>
-            <a:ext cx="5303520" cy="4572000"/>
-          </a:xfrm>
-          <a:prstGeom prst="rect">
-            <a:avLst/>
-          </a:prstGeom>
-          <a:noFill/>
-        </p:spPr>
-        <p:txBody>
-          <a:bodyPr wrap="square">
-            <a:spAutoFit/>
-          </a:bodyPr>
-          <a:lstStyle/>
-          <a:p>
-            <a:pPr>
-              <a:spcAft>
-                <a:spcPts val="1000"/>
-              </a:spcAft>
-              <a:defRPr sz="2000" b="1">
-                <a:solidFill>
-                  <a:srgbClr val="2563EB"/>
-                </a:solidFill>
-              </a:defRPr>
-            </a:pPr>
-            <a:r>
-              <a:t>🎯 Project Objectives</a:t>
-            </a:r>
-          </a:p>
-          <a:p>
-            <a:pPr>
-              <a:spcAft>
-                <a:spcPts val="1200"/>
-              </a:spcAft>
-              <a:defRPr sz="1400">
-                <a:solidFill>
-                  <a:srgbClr val="1E293B"/>
-                </a:solidFill>
-              </a:defRPr>
-            </a:pPr>
-            <a:r>
-              <a:t>✓ Build an ML model that predicts borrower default risk accurately.</a:t>
-            </a:r>
-          </a:p>
-          <a:p>
-            <a:pPr>
-              <a:spcAft>
-                <a:spcPts val="1200"/>
-              </a:spcAft>
-              <a:defRPr sz="1400">
-                <a:solidFill>
-                  <a:srgbClr val="1E293B"/>
-                </a:solidFill>
-              </a:defRPr>
-            </a:pPr>
-            <a:r>
-              <a:t>✓ Optimize the classification threshold for Recall to capture the maximum number of potential defaults.</a:t>
-            </a:r>
-          </a:p>
-          <a:p>
-            <a:pPr>
-              <a:spcAft>
-                <a:spcPts val="1200"/>
-              </a:spcAft>
-              <a:defRPr sz="1400">
-                <a:solidFill>
-                  <a:srgbClr val="1E293B"/>
-                </a:solidFill>
-              </a:defRPr>
-            </a:pPr>
-            <a:r>
-              <a:t>✓ Deploy a responsive, production-quality dashboard for risk assessment and real-time scenario simulation.</a:t>
+                  <a:srgbClr val="64748B"/>
+                </a:solidFill>
+              </a:defRPr>
+            </a:pPr>
+            <a:r>
+              <a:t>Domain: Data Analytics  |  Year: 2026</a:t>
             </a:r>
           </a:p>
         </p:txBody>
@@ -4503,7 +4651,7 @@
               </a:defRPr>
             </a:pPr>
             <a:r>
-              <a:t>Dataset Overview &amp; Data Pipeline</a:t>
+              <a:t>Problem Statement &amp; Objectives</a:t>
             </a:r>
           </a:p>
         </p:txBody>
@@ -4553,7 +4701,7 @@
         <p:spPr>
           <a:xfrm>
             <a:off x="548640" y="1463040"/>
-            <a:ext cx="4114800" cy="4572000"/>
+            <a:ext cx="5303520" cy="4572000"/>
           </a:xfrm>
           <a:prstGeom prst="rect">
             <a:avLst/>
@@ -4568,7 +4716,7 @@
           <a:p>
             <a:pPr>
               <a:spcAft>
-                <a:spcPts val="1400"/>
+                <a:spcPts val="1000"/>
               </a:spcAft>
               <a:defRPr sz="2000" b="1">
                 <a:solidFill>
@@ -4577,7 +4725,7 @@
               </a:defRPr>
             </a:pPr>
             <a:r>
-              <a:t>📊 Dataset Scale</a:t>
+              <a:t>🔴 The Core Challenge</a:t>
             </a:r>
           </a:p>
           <a:p>
@@ -4592,7 +4740,7 @@
               </a:defRPr>
             </a:pPr>
             <a:r>
-              <a:t>➤ Total Observations: 255,347 loans</a:t>
+              <a:t>• Financial institutions lose billions annually due to non-performing loans (defaults).</a:t>
             </a:r>
           </a:p>
           <a:p>
@@ -4607,7 +4755,7 @@
               </a:defRPr>
             </a:pPr>
             <a:r>
-              <a:t>➤ Number of Features: 17 columns</a:t>
+              <a:t>• Traditional credit scoring methods are static and miss complex risk factor interactions.</a:t>
             </a:r>
           </a:p>
           <a:p>
@@ -4622,22 +4770,7 @@
               </a:defRPr>
             </a:pPr>
             <a:r>
-              <a:t>➤ Target Variable: Default (0 = Repaid, 1 = Defaulted)</a:t>
-            </a:r>
-          </a:p>
-          <a:p>
-            <a:pPr>
-              <a:spcAft>
-                <a:spcPts val="1200"/>
-              </a:spcAft>
-              <a:defRPr sz="1400">
-                <a:solidFill>
-                  <a:srgbClr val="1E293B"/>
-                </a:solidFill>
-              </a:defRPr>
-            </a:pPr>
-            <a:r>
-              <a:t>➤ Imbalanced Classes: ~11.6% Default Rate</a:t>
+              <a:t>• Missing a default (False Negative) is highly critical and expensive compared to incorrectly declining a good customer (False Positive).</a:t>
             </a:r>
           </a:p>
         </p:txBody>
@@ -4650,8 +4783,8 @@
         </p:nvSpPr>
         <p:spPr>
           <a:xfrm>
-            <a:off x="5029200" y="1463040"/>
-            <a:ext cx="6583680" cy="4572000"/>
+            <a:off x="6217920" y="1463040"/>
+            <a:ext cx="5303520" cy="4572000"/>
           </a:xfrm>
           <a:prstGeom prst="rect">
             <a:avLst/>
@@ -4666,7 +4799,7 @@
           <a:p>
             <a:pPr>
               <a:spcAft>
-                <a:spcPts val="1400"/>
+                <a:spcPts val="1000"/>
               </a:spcAft>
               <a:defRPr sz="2000" b="1">
                 <a:solidFill>
@@ -4675,13 +4808,13 @@
               </a:defRPr>
             </a:pPr>
             <a:r>
-              <a:t>⚙️ Engineering Pipeline</a:t>
-            </a:r>
-          </a:p>
-          <a:p>
-            <a:pPr>
-              <a:spcAft>
-                <a:spcPts val="1000"/>
+              <a:t>🎯 Project Objectives</a:t>
+            </a:r>
+          </a:p>
+          <a:p>
+            <a:pPr>
+              <a:spcAft>
+                <a:spcPts val="1200"/>
               </a:spcAft>
               <a:defRPr sz="1400">
                 <a:solidFill>
@@ -4690,13 +4823,13 @@
               </a:defRPr>
             </a:pPr>
             <a:r>
-              <a:t>• Data Cleaning: Verified integrity, handled missing inputs, validated formats.</a:t>
-            </a:r>
-          </a:p>
-          <a:p>
-            <a:pPr>
-              <a:spcAft>
-                <a:spcPts val="1000"/>
+              <a:t>✓ Build an ML model that predicts borrower default risk accurately.</a:t>
+            </a:r>
+          </a:p>
+          <a:p>
+            <a:pPr>
+              <a:spcAft>
+                <a:spcPts val="1200"/>
               </a:spcAft>
               <a:defRPr sz="1400">
                 <a:solidFill>
@@ -4705,13 +4838,13 @@
               </a:defRPr>
             </a:pPr>
             <a:r>
-              <a:t>• Categorical Encoding: Mapped text fields (Education, EmploymentType, MaritalStatus, LoanPurpose, Yes/No fields) using scikit-learn LabelEncoder.</a:t>
-            </a:r>
-          </a:p>
-          <a:p>
-            <a:pPr>
-              <a:spcAft>
-                <a:spcPts val="1000"/>
+              <a:t>✓ Optimize the classification threshold for Recall to capture the maximum number of potential defaults.</a:t>
+            </a:r>
+          </a:p>
+          <a:p>
+            <a:pPr>
+              <a:spcAft>
+                <a:spcPts val="1200"/>
               </a:spcAft>
               <a:defRPr sz="1400">
                 <a:solidFill>
@@ -4720,22 +4853,7 @@
               </a:defRPr>
             </a:pPr>
             <a:r>
-              <a:t>• Feature Scaling: Normalised variables like Income and Credit Score with StandardScaler to aid convergence.</a:t>
-            </a:r>
-          </a:p>
-          <a:p>
-            <a:pPr>
-              <a:spcAft>
-                <a:spcPts val="1000"/>
-              </a:spcAft>
-              <a:defRPr sz="1400">
-                <a:solidFill>
-                  <a:srgbClr val="1E293B"/>
-                </a:solidFill>
-              </a:defRPr>
-            </a:pPr>
-            <a:r>
-              <a:t>• Stratification: Preserved the 11.6% default ratio during splits.</a:t>
+              <a:t>✓ Deploy a responsive, production-quality dashboard for risk assessment and real-time scenario simulation.</a:t>
             </a:r>
           </a:p>
         </p:txBody>
@@ -4875,7 +4993,7 @@
               </a:defRPr>
             </a:pPr>
             <a:r>
-              <a:t>Key Exploratory Data Analysis (EDA) Findings</a:t>
+              <a:t>Dataset Overview &amp; Data Pipeline</a:t>
             </a:r>
           </a:p>
         </p:txBody>
@@ -4924,8 +5042,8 @@
         </p:nvSpPr>
         <p:spPr>
           <a:xfrm>
-            <a:off x="548640" y="1645920"/>
-            <a:ext cx="3383280" cy="4114800"/>
+            <a:off x="548640" y="1463040"/>
+            <a:ext cx="4114800" cy="4572000"/>
           </a:xfrm>
           <a:prstGeom prst="rect">
             <a:avLst/>
@@ -4940,61 +5058,76 @@
           <a:p>
             <a:pPr>
               <a:spcAft>
-                <a:spcPts val="1000"/>
-              </a:spcAft>
-              <a:defRPr sz="1800" b="1">
+                <a:spcPts val="1400"/>
+              </a:spcAft>
+              <a:defRPr sz="2000" b="1">
                 <a:solidFill>
                   <a:srgbClr val="2563EB"/>
                 </a:solidFill>
               </a:defRPr>
             </a:pPr>
             <a:r>
-              <a:t>💳 Interest Rates &amp; Default</a:t>
-            </a:r>
-          </a:p>
-          <a:p>
-            <a:pPr>
-              <a:spcAft>
-                <a:spcPts val="800"/>
-              </a:spcAft>
-              <a:defRPr sz="1300">
+              <a:t>📊 Dataset Scale</a:t>
+            </a:r>
+          </a:p>
+          <a:p>
+            <a:pPr>
+              <a:spcAft>
+                <a:spcPts val="1200"/>
+              </a:spcAft>
+              <a:defRPr sz="1400">
                 <a:solidFill>
                   <a:srgbClr val="1E293B"/>
                 </a:solidFill>
               </a:defRPr>
             </a:pPr>
             <a:r>
-              <a:t>• A clear, exponential risk increase matches higher interest rates.</a:t>
-            </a:r>
-          </a:p>
-          <a:p>
-            <a:pPr>
-              <a:spcAft>
-                <a:spcPts val="800"/>
-              </a:spcAft>
-              <a:defRPr sz="1300">
+              <a:t>➤ Total Observations: 255,347 loans</a:t>
+            </a:r>
+          </a:p>
+          <a:p>
+            <a:pPr>
+              <a:spcAft>
+                <a:spcPts val="1200"/>
+              </a:spcAft>
+              <a:defRPr sz="1400">
                 <a:solidFill>
                   <a:srgbClr val="1E293B"/>
                 </a:solidFill>
               </a:defRPr>
             </a:pPr>
             <a:r>
-              <a:t>• Borrowers assigned rates over 15% exhibit elevated default probabilities.</a:t>
-            </a:r>
-          </a:p>
-          <a:p>
-            <a:pPr>
-              <a:spcAft>
-                <a:spcPts val="800"/>
-              </a:spcAft>
-              <a:defRPr sz="1300">
+              <a:t>➤ Number of Features: 17 columns</a:t>
+            </a:r>
+          </a:p>
+          <a:p>
+            <a:pPr>
+              <a:spcAft>
+                <a:spcPts val="1200"/>
+              </a:spcAft>
+              <a:defRPr sz="1400">
                 <a:solidFill>
                   <a:srgbClr val="1E293B"/>
                 </a:solidFill>
               </a:defRPr>
             </a:pPr>
             <a:r>
-              <a:t>• Suggests that aggressive pricing strategies worsen adverse selection.</a:t>
+              <a:t>➤ Target Variable: Default (0 = Repaid, 1 = Defaulted)</a:t>
+            </a:r>
+          </a:p>
+          <a:p>
+            <a:pPr>
+              <a:spcAft>
+                <a:spcPts val="1200"/>
+              </a:spcAft>
+              <a:defRPr sz="1400">
+                <a:solidFill>
+                  <a:srgbClr val="1E293B"/>
+                </a:solidFill>
+              </a:defRPr>
+            </a:pPr>
+            <a:r>
+              <a:t>➤ Imbalanced Classes: ~11.6% Default Rate</a:t>
             </a:r>
           </a:p>
         </p:txBody>
@@ -5007,8 +5140,8 @@
         </p:nvSpPr>
         <p:spPr>
           <a:xfrm>
-            <a:off x="4297680" y="1645920"/>
-            <a:ext cx="3383280" cy="4114800"/>
+            <a:off x="5029200" y="1463040"/>
+            <a:ext cx="6583680" cy="4572000"/>
           </a:xfrm>
           <a:prstGeom prst="rect">
             <a:avLst/>
@@ -5023,144 +5156,76 @@
           <a:p>
             <a:pPr>
               <a:spcAft>
+                <a:spcPts val="1400"/>
+              </a:spcAft>
+              <a:defRPr sz="2000" b="1">
+                <a:solidFill>
+                  <a:srgbClr val="2563EB"/>
+                </a:solidFill>
+              </a:defRPr>
+            </a:pPr>
+            <a:r>
+              <a:t>⚙️ Engineering Pipeline</a:t>
+            </a:r>
+          </a:p>
+          <a:p>
+            <a:pPr>
+              <a:spcAft>
                 <a:spcPts val="1000"/>
               </a:spcAft>
-              <a:defRPr sz="1800" b="1">
-                <a:solidFill>
-                  <a:srgbClr val="2563EB"/>
-                </a:solidFill>
-              </a:defRPr>
-            </a:pPr>
-            <a:r>
-              <a:t>📊 Debt-to-Income (DTI)</a:t>
-            </a:r>
-          </a:p>
-          <a:p>
-            <a:pPr>
-              <a:spcAft>
-                <a:spcPts val="800"/>
-              </a:spcAft>
-              <a:defRPr sz="1300">
+              <a:defRPr sz="1400">
                 <a:solidFill>
                   <a:srgbClr val="1E293B"/>
                 </a:solidFill>
               </a:defRPr>
             </a:pPr>
             <a:r>
-              <a:t>• DTI represents a critical credit risk factor.</a:t>
-            </a:r>
-          </a:p>
-          <a:p>
-            <a:pPr>
-              <a:spcAft>
-                <a:spcPts val="800"/>
-              </a:spcAft>
-              <a:defRPr sz="1300">
+              <a:t>• Data Cleaning: Verified integrity, handled missing inputs, validated formats.</a:t>
+            </a:r>
+          </a:p>
+          <a:p>
+            <a:pPr>
+              <a:spcAft>
+                <a:spcPts val="1000"/>
+              </a:spcAft>
+              <a:defRPr sz="1400">
                 <a:solidFill>
                   <a:srgbClr val="1E293B"/>
                 </a:solidFill>
               </a:defRPr>
             </a:pPr>
             <a:r>
-              <a:t>• Default risk spikes when DTI ratios exceed 40%, pointing to borrower over-leverage.</a:t>
-            </a:r>
-          </a:p>
-          <a:p>
-            <a:pPr>
-              <a:spcAft>
-                <a:spcPts val="800"/>
-              </a:spcAft>
-              <a:defRPr sz="1300">
+              <a:t>• Categorical Encoding: Mapped text fields (Education, EmploymentType, MaritalStatus, LoanPurpose, Yes/No fields) using scikit-learn LabelEncoder.</a:t>
+            </a:r>
+          </a:p>
+          <a:p>
+            <a:pPr>
+              <a:spcAft>
+                <a:spcPts val="1000"/>
+              </a:spcAft>
+              <a:defRPr sz="1400">
                 <a:solidFill>
                   <a:srgbClr val="1E293B"/>
                 </a:solidFill>
               </a:defRPr>
             </a:pPr>
             <a:r>
-              <a:t>• Essential to check DTI along with absolute income.</a:t>
-            </a:r>
-          </a:p>
-        </p:txBody>
-      </p:sp>
-      <p:sp>
-        <p:nvSpPr>
-          <p:cNvPr id="8" name="TextBox 7"/>
-          <p:cNvSpPr txBox="1"/>
-          <p:nvPr/>
-        </p:nvSpPr>
-        <p:spPr>
-          <a:xfrm>
-            <a:off x="8046720" y="1645920"/>
-            <a:ext cx="3383280" cy="4114800"/>
-          </a:xfrm>
-          <a:prstGeom prst="rect">
-            <a:avLst/>
-          </a:prstGeom>
-          <a:noFill/>
-        </p:spPr>
-        <p:txBody>
-          <a:bodyPr wrap="square">
-            <a:spAutoFit/>
-          </a:bodyPr>
-          <a:lstStyle/>
+              <a:t>• Feature Scaling: Normalised variables like Income and Credit Score with StandardScaler to aid convergence.</a:t>
+            </a:r>
+          </a:p>
           <a:p>
             <a:pPr>
               <a:spcAft>
                 <a:spcPts val="1000"/>
               </a:spcAft>
-              <a:defRPr sz="1800" b="1">
-                <a:solidFill>
-                  <a:srgbClr val="2563EB"/>
-                </a:solidFill>
-              </a:defRPr>
-            </a:pPr>
-            <a:r>
-              <a:t>🤝 Has Co-Signer Influence</a:t>
-            </a:r>
-          </a:p>
-          <a:p>
-            <a:pPr>
-              <a:spcAft>
-                <a:spcPts val="800"/>
-              </a:spcAft>
-              <a:defRPr sz="1300">
+              <a:defRPr sz="1400">
                 <a:solidFill>
                   <a:srgbClr val="1E293B"/>
                 </a:solidFill>
               </a:defRPr>
             </a:pPr>
             <a:r>
-              <a:t>• A co-signer functions as an effective risk mitigator.</a:t>
-            </a:r>
-          </a:p>
-          <a:p>
-            <a:pPr>
-              <a:spcAft>
-                <a:spcPts val="800"/>
-              </a:spcAft>
-              <a:defRPr sz="1300">
-                <a:solidFill>
-                  <a:srgbClr val="1E293B"/>
-                </a:solidFill>
-              </a:defRPr>
-            </a:pPr>
-            <a:r>
-              <a:t>• The default rate among borrowers with co-signers drops significantly.</a:t>
-            </a:r>
-          </a:p>
-          <a:p>
-            <a:pPr>
-              <a:spcAft>
-                <a:spcPts val="800"/>
-              </a:spcAft>
-              <a:defRPr sz="1300">
-                <a:solidFill>
-                  <a:srgbClr val="1E293B"/>
-                </a:solidFill>
-              </a:defRPr>
-            </a:pPr>
-            <a:r>
-              <a:t>• Highlights the value of shared legal liability in risk models.</a:t>
+              <a:t>• Stratification: Preserved the 11.6% default ratio during splits.</a:t>
             </a:r>
           </a:p>
         </p:txBody>
@@ -5174,6 +5239,431 @@
 </file>
 
 <file path=ppt/slides/slide5.xml><?xml version="1.0" encoding="utf-8"?>
+<p:sld xmlns:a="http://schemas.openxmlformats.org/drawingml/2006/main" xmlns:p="http://schemas.openxmlformats.org/presentationml/2006/main" xmlns:r="http://schemas.openxmlformats.org/officeDocument/2006/relationships">
+  <p:cSld>
+    <p:spTree>
+      <p:nvGrpSpPr>
+        <p:cNvPr id="1" name=""/>
+        <p:cNvGrpSpPr/>
+        <p:nvPr/>
+      </p:nvGrpSpPr>
+      <p:grpSpPr/>
+      <p:sp>
+        <p:nvSpPr>
+          <p:cNvPr id="2" name="Rectangle 1"/>
+          <p:cNvSpPr/>
+          <p:nvPr/>
+        </p:nvSpPr>
+        <p:spPr>
+          <a:xfrm>
+            <a:off x="0" y="0"/>
+            <a:ext cx="12191695" cy="6858000"/>
+          </a:xfrm>
+          <a:prstGeom prst="rect">
+            <a:avLst/>
+          </a:prstGeom>
+          <a:solidFill>
+            <a:srgbClr val="F8FAFC"/>
+          </a:solidFill>
+          <a:ln>
+            <a:noFill/>
+          </a:ln>
+        </p:spPr>
+        <p:style>
+          <a:lnRef idx="1">
+            <a:schemeClr val="accent1"/>
+          </a:lnRef>
+          <a:fillRef idx="3">
+            <a:schemeClr val="accent1"/>
+          </a:fillRef>
+          <a:effectRef idx="2">
+            <a:schemeClr val="accent1"/>
+          </a:effectRef>
+          <a:fontRef idx="minor">
+            <a:schemeClr val="lt1"/>
+          </a:fontRef>
+        </p:style>
+        <p:txBody>
+          <a:bodyPr rtlCol="0" anchor="ctr"/>
+          <a:lstStyle/>
+          <a:p>
+            <a:pPr algn="ctr"/>
+          </a:p>
+        </p:txBody>
+      </p:sp>
+      <p:sp>
+        <p:nvSpPr>
+          <p:cNvPr id="3" name="Rectangle 2"/>
+          <p:cNvSpPr/>
+          <p:nvPr/>
+        </p:nvSpPr>
+        <p:spPr>
+          <a:xfrm>
+            <a:off x="0" y="0"/>
+            <a:ext cx="12191695" cy="1005840"/>
+          </a:xfrm>
+          <a:prstGeom prst="rect">
+            <a:avLst/>
+          </a:prstGeom>
+          <a:solidFill>
+            <a:srgbClr val="0F172A"/>
+          </a:solidFill>
+          <a:ln>
+            <a:noFill/>
+          </a:ln>
+        </p:spPr>
+        <p:style>
+          <a:lnRef idx="1">
+            <a:schemeClr val="accent1"/>
+          </a:lnRef>
+          <a:fillRef idx="3">
+            <a:schemeClr val="accent1"/>
+          </a:fillRef>
+          <a:effectRef idx="2">
+            <a:schemeClr val="accent1"/>
+          </a:effectRef>
+          <a:fontRef idx="minor">
+            <a:schemeClr val="lt1"/>
+          </a:fontRef>
+        </p:style>
+        <p:txBody>
+          <a:bodyPr rtlCol="0" anchor="ctr"/>
+          <a:lstStyle/>
+          <a:p>
+            <a:pPr algn="ctr"/>
+          </a:p>
+        </p:txBody>
+      </p:sp>
+      <p:sp>
+        <p:nvSpPr>
+          <p:cNvPr id="4" name="TextBox 3"/>
+          <p:cNvSpPr txBox="1"/>
+          <p:nvPr/>
+        </p:nvSpPr>
+        <p:spPr>
+          <a:xfrm>
+            <a:off x="548640" y="182880"/>
+            <a:ext cx="10972800" cy="731520"/>
+          </a:xfrm>
+          <a:prstGeom prst="rect">
+            <a:avLst/>
+          </a:prstGeom>
+          <a:noFill/>
+        </p:spPr>
+        <p:txBody>
+          <a:bodyPr wrap="square">
+            <a:spAutoFit/>
+          </a:bodyPr>
+          <a:lstStyle/>
+          <a:p>
+            <a:pPr>
+              <a:defRPr sz="2800" b="1">
+                <a:solidFill>
+                  <a:srgbClr val="FFFFFF"/>
+                </a:solidFill>
+                <a:latin typeface="Arial"/>
+              </a:defRPr>
+            </a:pPr>
+            <a:r>
+              <a:t>Key Exploratory Data Analysis (EDA) Findings</a:t>
+            </a:r>
+          </a:p>
+        </p:txBody>
+      </p:sp>
+      <p:sp>
+        <p:nvSpPr>
+          <p:cNvPr id="5" name="TextBox 4"/>
+          <p:cNvSpPr txBox="1"/>
+          <p:nvPr/>
+        </p:nvSpPr>
+        <p:spPr>
+          <a:xfrm>
+            <a:off x="548640" y="6492240"/>
+            <a:ext cx="10972800" cy="274320"/>
+          </a:xfrm>
+          <a:prstGeom prst="rect">
+            <a:avLst/>
+          </a:prstGeom>
+          <a:noFill/>
+        </p:spPr>
+        <p:txBody>
+          <a:bodyPr wrap="none">
+            <a:spAutoFit/>
+          </a:bodyPr>
+          <a:lstStyle/>
+          <a:p>
+            <a:pPr>
+              <a:defRPr sz="1000">
+                <a:solidFill>
+                  <a:srgbClr val="64748B"/>
+                </a:solidFill>
+                <a:latin typeface="Arial"/>
+              </a:defRPr>
+            </a:pPr>
+            <a:r>
+              <a:t>Internship Project  |  Data Analytics  |  Year 2026</a:t>
+            </a:r>
+          </a:p>
+        </p:txBody>
+      </p:sp>
+      <p:sp>
+        <p:nvSpPr>
+          <p:cNvPr id="6" name="TextBox 5"/>
+          <p:cNvSpPr txBox="1"/>
+          <p:nvPr/>
+        </p:nvSpPr>
+        <p:spPr>
+          <a:xfrm>
+            <a:off x="548640" y="1645920"/>
+            <a:ext cx="3383280" cy="4114800"/>
+          </a:xfrm>
+          <a:prstGeom prst="rect">
+            <a:avLst/>
+          </a:prstGeom>
+          <a:noFill/>
+        </p:spPr>
+        <p:txBody>
+          <a:bodyPr wrap="square">
+            <a:spAutoFit/>
+          </a:bodyPr>
+          <a:lstStyle/>
+          <a:p>
+            <a:pPr>
+              <a:spcAft>
+                <a:spcPts val="1000"/>
+              </a:spcAft>
+              <a:defRPr sz="1800" b="1">
+                <a:solidFill>
+                  <a:srgbClr val="2563EB"/>
+                </a:solidFill>
+              </a:defRPr>
+            </a:pPr>
+            <a:r>
+              <a:t>💳 Interest Rates &amp; Default</a:t>
+            </a:r>
+          </a:p>
+          <a:p>
+            <a:pPr>
+              <a:spcAft>
+                <a:spcPts val="800"/>
+              </a:spcAft>
+              <a:defRPr sz="1300">
+                <a:solidFill>
+                  <a:srgbClr val="1E293B"/>
+                </a:solidFill>
+              </a:defRPr>
+            </a:pPr>
+            <a:r>
+              <a:t>• A clear, exponential risk increase matches higher interest rates.</a:t>
+            </a:r>
+          </a:p>
+          <a:p>
+            <a:pPr>
+              <a:spcAft>
+                <a:spcPts val="800"/>
+              </a:spcAft>
+              <a:defRPr sz="1300">
+                <a:solidFill>
+                  <a:srgbClr val="1E293B"/>
+                </a:solidFill>
+              </a:defRPr>
+            </a:pPr>
+            <a:r>
+              <a:t>• Borrowers assigned rates over 15% exhibit elevated default probabilities.</a:t>
+            </a:r>
+          </a:p>
+          <a:p>
+            <a:pPr>
+              <a:spcAft>
+                <a:spcPts val="800"/>
+              </a:spcAft>
+              <a:defRPr sz="1300">
+                <a:solidFill>
+                  <a:srgbClr val="1E293B"/>
+                </a:solidFill>
+              </a:defRPr>
+            </a:pPr>
+            <a:r>
+              <a:t>• Suggests that aggressive pricing strategies worsen adverse selection.</a:t>
+            </a:r>
+          </a:p>
+        </p:txBody>
+      </p:sp>
+      <p:sp>
+        <p:nvSpPr>
+          <p:cNvPr id="7" name="TextBox 6"/>
+          <p:cNvSpPr txBox="1"/>
+          <p:nvPr/>
+        </p:nvSpPr>
+        <p:spPr>
+          <a:xfrm>
+            <a:off x="4297680" y="1645920"/>
+            <a:ext cx="3383280" cy="4114800"/>
+          </a:xfrm>
+          <a:prstGeom prst="rect">
+            <a:avLst/>
+          </a:prstGeom>
+          <a:noFill/>
+        </p:spPr>
+        <p:txBody>
+          <a:bodyPr wrap="square">
+            <a:spAutoFit/>
+          </a:bodyPr>
+          <a:lstStyle/>
+          <a:p>
+            <a:pPr>
+              <a:spcAft>
+                <a:spcPts val="1000"/>
+              </a:spcAft>
+              <a:defRPr sz="1800" b="1">
+                <a:solidFill>
+                  <a:srgbClr val="2563EB"/>
+                </a:solidFill>
+              </a:defRPr>
+            </a:pPr>
+            <a:r>
+              <a:t>📊 Debt-to-Income (DTI)</a:t>
+            </a:r>
+          </a:p>
+          <a:p>
+            <a:pPr>
+              <a:spcAft>
+                <a:spcPts val="800"/>
+              </a:spcAft>
+              <a:defRPr sz="1300">
+                <a:solidFill>
+                  <a:srgbClr val="1E293B"/>
+                </a:solidFill>
+              </a:defRPr>
+            </a:pPr>
+            <a:r>
+              <a:t>• DTI represents a critical credit risk factor.</a:t>
+            </a:r>
+          </a:p>
+          <a:p>
+            <a:pPr>
+              <a:spcAft>
+                <a:spcPts val="800"/>
+              </a:spcAft>
+              <a:defRPr sz="1300">
+                <a:solidFill>
+                  <a:srgbClr val="1E293B"/>
+                </a:solidFill>
+              </a:defRPr>
+            </a:pPr>
+            <a:r>
+              <a:t>• Default risk spikes when DTI ratios exceed 40%, pointing to borrower over-leverage.</a:t>
+            </a:r>
+          </a:p>
+          <a:p>
+            <a:pPr>
+              <a:spcAft>
+                <a:spcPts val="800"/>
+              </a:spcAft>
+              <a:defRPr sz="1300">
+                <a:solidFill>
+                  <a:srgbClr val="1E293B"/>
+                </a:solidFill>
+              </a:defRPr>
+            </a:pPr>
+            <a:r>
+              <a:t>• Essential to check DTI along with absolute income.</a:t>
+            </a:r>
+          </a:p>
+        </p:txBody>
+      </p:sp>
+      <p:sp>
+        <p:nvSpPr>
+          <p:cNvPr id="8" name="TextBox 7"/>
+          <p:cNvSpPr txBox="1"/>
+          <p:nvPr/>
+        </p:nvSpPr>
+        <p:spPr>
+          <a:xfrm>
+            <a:off x="8046720" y="1645920"/>
+            <a:ext cx="3383280" cy="4114800"/>
+          </a:xfrm>
+          <a:prstGeom prst="rect">
+            <a:avLst/>
+          </a:prstGeom>
+          <a:noFill/>
+        </p:spPr>
+        <p:txBody>
+          <a:bodyPr wrap="square">
+            <a:spAutoFit/>
+          </a:bodyPr>
+          <a:lstStyle/>
+          <a:p>
+            <a:pPr>
+              <a:spcAft>
+                <a:spcPts val="1000"/>
+              </a:spcAft>
+              <a:defRPr sz="1800" b="1">
+                <a:solidFill>
+                  <a:srgbClr val="2563EB"/>
+                </a:solidFill>
+              </a:defRPr>
+            </a:pPr>
+            <a:r>
+              <a:t>🤝 Has Co-Signer Influence</a:t>
+            </a:r>
+          </a:p>
+          <a:p>
+            <a:pPr>
+              <a:spcAft>
+                <a:spcPts val="800"/>
+              </a:spcAft>
+              <a:defRPr sz="1300">
+                <a:solidFill>
+                  <a:srgbClr val="1E293B"/>
+                </a:solidFill>
+              </a:defRPr>
+            </a:pPr>
+            <a:r>
+              <a:t>• A co-signer functions as an effective risk mitigator.</a:t>
+            </a:r>
+          </a:p>
+          <a:p>
+            <a:pPr>
+              <a:spcAft>
+                <a:spcPts val="800"/>
+              </a:spcAft>
+              <a:defRPr sz="1300">
+                <a:solidFill>
+                  <a:srgbClr val="1E293B"/>
+                </a:solidFill>
+              </a:defRPr>
+            </a:pPr>
+            <a:r>
+              <a:t>• The default rate among borrowers with co-signers drops significantly.</a:t>
+            </a:r>
+          </a:p>
+          <a:p>
+            <a:pPr>
+              <a:spcAft>
+                <a:spcPts val="800"/>
+              </a:spcAft>
+              <a:defRPr sz="1300">
+                <a:solidFill>
+                  <a:srgbClr val="1E293B"/>
+                </a:solidFill>
+              </a:defRPr>
+            </a:pPr>
+            <a:r>
+              <a:t>• Highlights the value of shared legal liability in risk models.</a:t>
+            </a:r>
+          </a:p>
+        </p:txBody>
+      </p:sp>
+    </p:spTree>
+  </p:cSld>
+  <p:clrMapOvr>
+    <a:masterClrMapping/>
+  </p:clrMapOvr>
+</p:sld>
+</file>
+
+<file path=ppt/slides/slide6.xml><?xml version="1.0" encoding="utf-8"?>
 <p:sld xmlns:a="http://schemas.openxmlformats.org/drawingml/2006/main" xmlns:p="http://schemas.openxmlformats.org/presentationml/2006/main" xmlns:r="http://schemas.openxmlformats.org/officeDocument/2006/relationships">
   <p:cSld>
     <p:spTree>
@@ -6269,7 +6759,7 @@
 </p:sld>
 </file>
 
-<file path=ppt/slides/slide6.xml><?xml version="1.0" encoding="utf-8"?>
+<file path=ppt/slides/slide7.xml><?xml version="1.0" encoding="utf-8"?>
 <p:sld xmlns:a="http://schemas.openxmlformats.org/drawingml/2006/main" xmlns:p="http://schemas.openxmlformats.org/presentationml/2006/main" xmlns:r="http://schemas.openxmlformats.org/officeDocument/2006/relationships">
   <p:cSld>
     <p:spTree>
@@ -6611,7 +7101,7 @@
 </p:sld>
 </file>
 
-<file path=ppt/slides/slide7.xml><?xml version="1.0" encoding="utf-8"?>
+<file path=ppt/slides/slide8.xml><?xml version="1.0" encoding="utf-8"?>
 <p:sld xmlns:a="http://schemas.openxmlformats.org/drawingml/2006/main" xmlns:p="http://schemas.openxmlformats.org/presentationml/2006/main" xmlns:r="http://schemas.openxmlformats.org/officeDocument/2006/relationships">
   <p:cSld>
     <p:spTree>
@@ -7198,7 +7688,7 @@
 </p:sld>
 </file>
 
-<file path=ppt/slides/slide8.xml><?xml version="1.0" encoding="utf-8"?>
+<file path=ppt/slides/slide9.xml><?xml version="1.0" encoding="utf-8"?>
 <p:sld xmlns:a="http://schemas.openxmlformats.org/drawingml/2006/main" xmlns:p="http://schemas.openxmlformats.org/presentationml/2006/main" xmlns:r="http://schemas.openxmlformats.org/officeDocument/2006/relationships">
   <p:cSld>
     <p:spTree>
@@ -7738,453 +8228,6 @@
             </a:pPr>
             <a:r>
               <a:t>• False Negatives: 2,967 defaults were missed. Reducing this rate further represents a path for future iterations.</a:t>
-            </a:r>
-          </a:p>
-        </p:txBody>
-      </p:sp>
-    </p:spTree>
-  </p:cSld>
-  <p:clrMapOvr>
-    <a:masterClrMapping/>
-  </p:clrMapOvr>
-</p:sld>
-</file>
-
-<file path=ppt/slides/slide9.xml><?xml version="1.0" encoding="utf-8"?>
-<p:sld xmlns:a="http://schemas.openxmlformats.org/drawingml/2006/main" xmlns:p="http://schemas.openxmlformats.org/presentationml/2006/main" xmlns:r="http://schemas.openxmlformats.org/officeDocument/2006/relationships">
-  <p:cSld>
-    <p:spTree>
-      <p:nvGrpSpPr>
-        <p:cNvPr id="1" name=""/>
-        <p:cNvGrpSpPr/>
-        <p:nvPr/>
-      </p:nvGrpSpPr>
-      <p:grpSpPr/>
-      <p:sp>
-        <p:nvSpPr>
-          <p:cNvPr id="2" name="Rectangle 1"/>
-          <p:cNvSpPr/>
-          <p:nvPr/>
-        </p:nvSpPr>
-        <p:spPr>
-          <a:xfrm>
-            <a:off x="0" y="0"/>
-            <a:ext cx="12191695" cy="6858000"/>
-          </a:xfrm>
-          <a:prstGeom prst="rect">
-            <a:avLst/>
-          </a:prstGeom>
-          <a:solidFill>
-            <a:srgbClr val="F8FAFC"/>
-          </a:solidFill>
-          <a:ln>
-            <a:noFill/>
-          </a:ln>
-        </p:spPr>
-        <p:style>
-          <a:lnRef idx="1">
-            <a:schemeClr val="accent1"/>
-          </a:lnRef>
-          <a:fillRef idx="3">
-            <a:schemeClr val="accent1"/>
-          </a:fillRef>
-          <a:effectRef idx="2">
-            <a:schemeClr val="accent1"/>
-          </a:effectRef>
-          <a:fontRef idx="minor">
-            <a:schemeClr val="lt1"/>
-          </a:fontRef>
-        </p:style>
-        <p:txBody>
-          <a:bodyPr rtlCol="0" anchor="ctr"/>
-          <a:lstStyle/>
-          <a:p>
-            <a:pPr algn="ctr"/>
-          </a:p>
-        </p:txBody>
-      </p:sp>
-      <p:sp>
-        <p:nvSpPr>
-          <p:cNvPr id="3" name="Rectangle 2"/>
-          <p:cNvSpPr/>
-          <p:nvPr/>
-        </p:nvSpPr>
-        <p:spPr>
-          <a:xfrm>
-            <a:off x="0" y="0"/>
-            <a:ext cx="12191695" cy="1005840"/>
-          </a:xfrm>
-          <a:prstGeom prst="rect">
-            <a:avLst/>
-          </a:prstGeom>
-          <a:solidFill>
-            <a:srgbClr val="0F172A"/>
-          </a:solidFill>
-          <a:ln>
-            <a:noFill/>
-          </a:ln>
-        </p:spPr>
-        <p:style>
-          <a:lnRef idx="1">
-            <a:schemeClr val="accent1"/>
-          </a:lnRef>
-          <a:fillRef idx="3">
-            <a:schemeClr val="accent1"/>
-          </a:fillRef>
-          <a:effectRef idx="2">
-            <a:schemeClr val="accent1"/>
-          </a:effectRef>
-          <a:fontRef idx="minor">
-            <a:schemeClr val="lt1"/>
-          </a:fontRef>
-        </p:style>
-        <p:txBody>
-          <a:bodyPr rtlCol="0" anchor="ctr"/>
-          <a:lstStyle/>
-          <a:p>
-            <a:pPr algn="ctr"/>
-          </a:p>
-        </p:txBody>
-      </p:sp>
-      <p:sp>
-        <p:nvSpPr>
-          <p:cNvPr id="4" name="TextBox 3"/>
-          <p:cNvSpPr txBox="1"/>
-          <p:nvPr/>
-        </p:nvSpPr>
-        <p:spPr>
-          <a:xfrm>
-            <a:off x="548640" y="182880"/>
-            <a:ext cx="10972800" cy="731520"/>
-          </a:xfrm>
-          <a:prstGeom prst="rect">
-            <a:avLst/>
-          </a:prstGeom>
-          <a:noFill/>
-        </p:spPr>
-        <p:txBody>
-          <a:bodyPr wrap="square">
-            <a:spAutoFit/>
-          </a:bodyPr>
-          <a:lstStyle/>
-          <a:p>
-            <a:pPr>
-              <a:defRPr sz="2800" b="1">
-                <a:solidFill>
-                  <a:srgbClr val="FFFFFF"/>
-                </a:solidFill>
-                <a:latin typeface="Arial"/>
-              </a:defRPr>
-            </a:pPr>
-            <a:r>
-              <a:t>Feature Importance Analysis</a:t>
-            </a:r>
-          </a:p>
-        </p:txBody>
-      </p:sp>
-      <p:sp>
-        <p:nvSpPr>
-          <p:cNvPr id="5" name="TextBox 4"/>
-          <p:cNvSpPr txBox="1"/>
-          <p:nvPr/>
-        </p:nvSpPr>
-        <p:spPr>
-          <a:xfrm>
-            <a:off x="548640" y="6492240"/>
-            <a:ext cx="10972800" cy="274320"/>
-          </a:xfrm>
-          <a:prstGeom prst="rect">
-            <a:avLst/>
-          </a:prstGeom>
-          <a:noFill/>
-        </p:spPr>
-        <p:txBody>
-          <a:bodyPr wrap="none">
-            <a:spAutoFit/>
-          </a:bodyPr>
-          <a:lstStyle/>
-          <a:p>
-            <a:pPr>
-              <a:defRPr sz="1000">
-                <a:solidFill>
-                  <a:srgbClr val="64748B"/>
-                </a:solidFill>
-                <a:latin typeface="Arial"/>
-              </a:defRPr>
-            </a:pPr>
-            <a:r>
-              <a:t>Internship Project  |  Data Analytics  |  Year 2026</a:t>
-            </a:r>
-          </a:p>
-        </p:txBody>
-      </p:sp>
-      <p:sp>
-        <p:nvSpPr>
-          <p:cNvPr id="6" name="TextBox 5"/>
-          <p:cNvSpPr txBox="1"/>
-          <p:nvPr/>
-        </p:nvSpPr>
-        <p:spPr>
-          <a:xfrm>
-            <a:off x="548640" y="1645920"/>
-            <a:ext cx="5303520" cy="4114800"/>
-          </a:xfrm>
-          <a:prstGeom prst="rect">
-            <a:avLst/>
-          </a:prstGeom>
-          <a:noFill/>
-        </p:spPr>
-        <p:txBody>
-          <a:bodyPr wrap="square">
-            <a:spAutoFit/>
-          </a:bodyPr>
-          <a:lstStyle/>
-          <a:p>
-            <a:pPr>
-              <a:spcAft>
-                <a:spcPts val="1000"/>
-              </a:spcAft>
-              <a:defRPr sz="2000" b="1">
-                <a:solidFill>
-                  <a:srgbClr val="2563EB"/>
-                </a:solidFill>
-              </a:defRPr>
-            </a:pPr>
-            <a:r>
-              <a:t>🏗️ Top 10 Most Important Features</a:t>
-            </a:r>
-          </a:p>
-          <a:p>
-            <a:pPr>
-              <a:spcAft>
-                <a:spcPts val="400"/>
-              </a:spcAft>
-              <a:defRPr sz="1350" b="1">
-                <a:solidFill>
-                  <a:srgbClr val="1E293B"/>
-                </a:solidFill>
-              </a:defRPr>
-            </a:pPr>
-            <a:r>
-              <a:t>1. Income (12.6%)</a:t>
-            </a:r>
-          </a:p>
-          <a:p>
-            <a:pPr>
-              <a:spcAft>
-                <a:spcPts val="400"/>
-              </a:spcAft>
-              <a:defRPr sz="1350" b="1">
-                <a:solidFill>
-                  <a:srgbClr val="1E293B"/>
-                </a:solidFill>
-              </a:defRPr>
-            </a:pPr>
-            <a:r>
-              <a:t>2. InterestRate (12.1%)</a:t>
-            </a:r>
-          </a:p>
-          <a:p>
-            <a:pPr>
-              <a:spcAft>
-                <a:spcPts val="400"/>
-              </a:spcAft>
-              <a:defRPr sz="1350" b="1">
-                <a:solidFill>
-                  <a:srgbClr val="1E293B"/>
-                </a:solidFill>
-              </a:defRPr>
-            </a:pPr>
-            <a:r>
-              <a:t>3. LoanAmount (11.3%)</a:t>
-            </a:r>
-          </a:p>
-          <a:p>
-            <a:pPr>
-              <a:spcAft>
-                <a:spcPts val="400"/>
-              </a:spcAft>
-              <a:defRPr sz="1350" b="1">
-                <a:solidFill>
-                  <a:srgbClr val="1E293B"/>
-                </a:solidFill>
-              </a:defRPr>
-            </a:pPr>
-            <a:r>
-              <a:t>4. Age (10.3%)</a:t>
-            </a:r>
-          </a:p>
-          <a:p>
-            <a:pPr>
-              <a:spcAft>
-                <a:spcPts val="400"/>
-              </a:spcAft>
-              <a:defRPr sz="1350" b="1">
-                <a:solidFill>
-                  <a:srgbClr val="1E293B"/>
-                </a:solidFill>
-              </a:defRPr>
-            </a:pPr>
-            <a:r>
-              <a:t>5. CreditScore (10.1%)</a:t>
-            </a:r>
-          </a:p>
-          <a:p>
-            <a:pPr>
-              <a:spcAft>
-                <a:spcPts val="400"/>
-              </a:spcAft>
-              <a:defRPr sz="1350" b="1">
-                <a:solidFill>
-                  <a:srgbClr val="1E293B"/>
-                </a:solidFill>
-              </a:defRPr>
-            </a:pPr>
-            <a:r>
-              <a:t>6. MonthsEmployed (9.8%)</a:t>
-            </a:r>
-          </a:p>
-          <a:p>
-            <a:pPr>
-              <a:spcAft>
-                <a:spcPts val="400"/>
-              </a:spcAft>
-              <a:defRPr sz="1350" b="1">
-                <a:solidFill>
-                  <a:srgbClr val="1E293B"/>
-                </a:solidFill>
-              </a:defRPr>
-            </a:pPr>
-            <a:r>
-              <a:t>7. DTIRatio (8.8%)</a:t>
-            </a:r>
-          </a:p>
-          <a:p>
-            <a:pPr>
-              <a:spcAft>
-                <a:spcPts val="400"/>
-              </a:spcAft>
-              <a:defRPr sz="1350" b="1">
-                <a:solidFill>
-                  <a:srgbClr val="1E293B"/>
-                </a:solidFill>
-              </a:defRPr>
-            </a:pPr>
-            <a:r>
-              <a:t>8. LoanTerm (4.1%)</a:t>
-            </a:r>
-          </a:p>
-          <a:p>
-            <a:pPr>
-              <a:spcAft>
-                <a:spcPts val="400"/>
-              </a:spcAft>
-              <a:defRPr sz="1350" b="1">
-                <a:solidFill>
-                  <a:srgbClr val="1E293B"/>
-                </a:solidFill>
-              </a:defRPr>
-            </a:pPr>
-            <a:r>
-              <a:t>9. NumCreditLines (3.3%)</a:t>
-            </a:r>
-          </a:p>
-          <a:p>
-            <a:pPr>
-              <a:spcAft>
-                <a:spcPts val="400"/>
-              </a:spcAft>
-              <a:defRPr sz="1350" b="1">
-                <a:solidFill>
-                  <a:srgbClr val="1E293B"/>
-                </a:solidFill>
-              </a:defRPr>
-            </a:pPr>
-            <a:r>
-              <a:t>10. EmploymentType (2.5%)</a:t>
-            </a:r>
-          </a:p>
-        </p:txBody>
-      </p:sp>
-      <p:sp>
-        <p:nvSpPr>
-          <p:cNvPr id="7" name="TextBox 6"/>
-          <p:cNvSpPr txBox="1"/>
-          <p:nvPr/>
-        </p:nvSpPr>
-        <p:spPr>
-          <a:xfrm>
-            <a:off x="6217920" y="1645920"/>
-            <a:ext cx="5303520" cy="4114800"/>
-          </a:xfrm>
-          <a:prstGeom prst="rect">
-            <a:avLst/>
-          </a:prstGeom>
-          <a:noFill/>
-        </p:spPr>
-        <p:txBody>
-          <a:bodyPr wrap="square">
-            <a:spAutoFit/>
-          </a:bodyPr>
-          <a:lstStyle/>
-          <a:p>
-            <a:pPr>
-              <a:spcAft>
-                <a:spcPts val="1200"/>
-              </a:spcAft>
-              <a:defRPr sz="2000" b="1">
-                <a:solidFill>
-                  <a:srgbClr val="2563EB"/>
-                </a:solidFill>
-              </a:defRPr>
-            </a:pPr>
-            <a:r>
-              <a:t>📊 Key Findings</a:t>
-            </a:r>
-          </a:p>
-          <a:p>
-            <a:pPr>
-              <a:spcAft>
-                <a:spcPts val="1000"/>
-              </a:spcAft>
-              <a:defRPr sz="1350">
-                <a:solidFill>
-                  <a:srgbClr val="1E293B"/>
-                </a:solidFill>
-              </a:defRPr>
-            </a:pPr>
-            <a:r>
-              <a:t>• Financial Strengths rule risk assessment: Income, Loan Amount, and DTI represent the most critical risk drivers.</a:t>
-            </a:r>
-          </a:p>
-          <a:p>
-            <a:pPr>
-              <a:spcAft>
-                <a:spcPts val="1000"/>
-              </a:spcAft>
-              <a:defRPr sz="1350">
-                <a:solidFill>
-                  <a:srgbClr val="1E293B"/>
-                </a:solidFill>
-              </a:defRPr>
-            </a:pPr>
-            <a:r>
-              <a:t>• Pricing risk: Interest Rate is a high predictor, indicating that borrowers assigned high-interest loans default at much higher rates.</a:t>
-            </a:r>
-          </a:p>
-          <a:p>
-            <a:pPr>
-              <a:spcAft>
-                <a:spcPts val="1000"/>
-              </a:spcAft>
-              <a:defRPr sz="1350">
-                <a:solidFill>
-                  <a:srgbClr val="1E293B"/>
-                </a:solidFill>
-              </a:defRPr>
-            </a:pPr>
-            <a:r>
-              <a:t>• Borrower history: Credit score, age, and employment stability (MonthsEmployed) provide critical contextual signals that prevent false approvals.</a:t>
             </a:r>
           </a:p>
         </p:txBody>

</xml_diff>